<commit_message>
CR-068–090: commit accumulated CosmicDesigner work and complete package
</commit_message>
<xml_diff>
--- a/복사 이미지들.pptx
+++ b/복사 이미지들.pptx
@@ -8,6 +8,8 @@
     <p:sldId id="256" r:id="rId2"/>
     <p:sldId id="257" r:id="rId3"/>
     <p:sldId id="258" r:id="rId4"/>
+    <p:sldId id="259" r:id="rId5"/>
+    <p:sldId id="260" r:id="rId6"/>
   </p:sldIdLst>
   <p:sldSz cx="12192000" cy="6858000"/>
   <p:notesSz cx="6858000" cy="9144000"/>
@@ -109,7 +111,7 @@
   <p:extLst>
     <p:ext uri="{EFAFB233-063F-42B5-8137-9DF3F51BA10A}">
       <p15:sldGuideLst xmlns:p15="http://schemas.microsoft.com/office/powerpoint/2012/main">
-        <p15:guide id="1" orient="horz" pos="2137" userDrawn="1">
+        <p15:guide id="1" orient="horz" pos="2115" userDrawn="1">
           <p15:clr>
             <a:srgbClr val="A4A3A4"/>
           </p15:clr>
@@ -272,7 +274,7 @@
           <a:p>
             <a:fld id="{47EE5C5B-B89B-4479-89BA-6490CD022B6B}" type="datetimeFigureOut">
               <a:rPr lang="ko-KR" altLang="en-US" smtClean="0"/>
-              <a:t>10-04(Sun)</a:t>
+              <a:t>10-07(Wed)</a:t>
             </a:fld>
             <a:endParaRPr lang="ko-KR" altLang="en-US"/>
           </a:p>
@@ -470,7 +472,7 @@
           <a:p>
             <a:fld id="{47EE5C5B-B89B-4479-89BA-6490CD022B6B}" type="datetimeFigureOut">
               <a:rPr lang="ko-KR" altLang="en-US" smtClean="0"/>
-              <a:t>10-04(Sun)</a:t>
+              <a:t>10-07(Wed)</a:t>
             </a:fld>
             <a:endParaRPr lang="ko-KR" altLang="en-US"/>
           </a:p>
@@ -678,7 +680,7 @@
           <a:p>
             <a:fld id="{47EE5C5B-B89B-4479-89BA-6490CD022B6B}" type="datetimeFigureOut">
               <a:rPr lang="ko-KR" altLang="en-US" smtClean="0"/>
-              <a:t>10-04(Sun)</a:t>
+              <a:t>10-07(Wed)</a:t>
             </a:fld>
             <a:endParaRPr lang="ko-KR" altLang="en-US"/>
           </a:p>
@@ -876,7 +878,7 @@
           <a:p>
             <a:fld id="{47EE5C5B-B89B-4479-89BA-6490CD022B6B}" type="datetimeFigureOut">
               <a:rPr lang="ko-KR" altLang="en-US" smtClean="0"/>
-              <a:t>10-04(Sun)</a:t>
+              <a:t>10-07(Wed)</a:t>
             </a:fld>
             <a:endParaRPr lang="ko-KR" altLang="en-US"/>
           </a:p>
@@ -1151,7 +1153,7 @@
           <a:p>
             <a:fld id="{47EE5C5B-B89B-4479-89BA-6490CD022B6B}" type="datetimeFigureOut">
               <a:rPr lang="ko-KR" altLang="en-US" smtClean="0"/>
-              <a:t>10-04(Sun)</a:t>
+              <a:t>10-07(Wed)</a:t>
             </a:fld>
             <a:endParaRPr lang="ko-KR" altLang="en-US"/>
           </a:p>
@@ -1416,7 +1418,7 @@
           <a:p>
             <a:fld id="{47EE5C5B-B89B-4479-89BA-6490CD022B6B}" type="datetimeFigureOut">
               <a:rPr lang="ko-KR" altLang="en-US" smtClean="0"/>
-              <a:t>10-04(Sun)</a:t>
+              <a:t>10-07(Wed)</a:t>
             </a:fld>
             <a:endParaRPr lang="ko-KR" altLang="en-US"/>
           </a:p>
@@ -1828,7 +1830,7 @@
           <a:p>
             <a:fld id="{47EE5C5B-B89B-4479-89BA-6490CD022B6B}" type="datetimeFigureOut">
               <a:rPr lang="ko-KR" altLang="en-US" smtClean="0"/>
-              <a:t>10-04(Sun)</a:t>
+              <a:t>10-07(Wed)</a:t>
             </a:fld>
             <a:endParaRPr lang="ko-KR" altLang="en-US"/>
           </a:p>
@@ -1969,7 +1971,7 @@
           <a:p>
             <a:fld id="{47EE5C5B-B89B-4479-89BA-6490CD022B6B}" type="datetimeFigureOut">
               <a:rPr lang="ko-KR" altLang="en-US" smtClean="0"/>
-              <a:t>10-04(Sun)</a:t>
+              <a:t>10-07(Wed)</a:t>
             </a:fld>
             <a:endParaRPr lang="ko-KR" altLang="en-US"/>
           </a:p>
@@ -2082,7 +2084,7 @@
           <a:p>
             <a:fld id="{47EE5C5B-B89B-4479-89BA-6490CD022B6B}" type="datetimeFigureOut">
               <a:rPr lang="ko-KR" altLang="en-US" smtClean="0"/>
-              <a:t>10-04(Sun)</a:t>
+              <a:t>10-07(Wed)</a:t>
             </a:fld>
             <a:endParaRPr lang="ko-KR" altLang="en-US"/>
           </a:p>
@@ -2393,7 +2395,7 @@
           <a:p>
             <a:fld id="{47EE5C5B-B89B-4479-89BA-6490CD022B6B}" type="datetimeFigureOut">
               <a:rPr lang="ko-KR" altLang="en-US" smtClean="0"/>
-              <a:t>10-04(Sun)</a:t>
+              <a:t>10-07(Wed)</a:t>
             </a:fld>
             <a:endParaRPr lang="ko-KR" altLang="en-US"/>
           </a:p>
@@ -2681,7 +2683,7 @@
           <a:p>
             <a:fld id="{47EE5C5B-B89B-4479-89BA-6490CD022B6B}" type="datetimeFigureOut">
               <a:rPr lang="ko-KR" altLang="en-US" smtClean="0"/>
-              <a:t>10-04(Sun)</a:t>
+              <a:t>10-07(Wed)</a:t>
             </a:fld>
             <a:endParaRPr lang="ko-KR" altLang="en-US"/>
           </a:p>
@@ -2922,7 +2924,7 @@
           <a:p>
             <a:fld id="{47EE5C5B-B89B-4479-89BA-6490CD022B6B}" type="datetimeFigureOut">
               <a:rPr lang="ko-KR" altLang="en-US" smtClean="0"/>
-              <a:t>10-04(Sun)</a:t>
+              <a:t>10-07(Wed)</a:t>
             </a:fld>
             <a:endParaRPr lang="ko-KR" altLang="en-US"/>
           </a:p>
@@ -4534,6 +4536,451 @@
 </p:sld>
 </file>
 
+<file path=ppt/slides/slide4.xml><?xml version="1.0" encoding="utf-8"?>
+<p:sld xmlns:a="http://schemas.openxmlformats.org/drawingml/2006/main" xmlns:r="http://schemas.openxmlformats.org/officeDocument/2006/relationships" xmlns:p="http://schemas.openxmlformats.org/presentationml/2006/main">
+  <p:cSld>
+    <p:spTree>
+      <p:nvGrpSpPr>
+        <p:cNvPr id="1" name=""/>
+        <p:cNvGrpSpPr/>
+        <p:nvPr/>
+      </p:nvGrpSpPr>
+      <p:grpSpPr>
+        <a:xfrm>
+          <a:off x="0" y="0"/>
+          <a:ext cx="0" cy="0"/>
+          <a:chOff x="0" y="0"/>
+          <a:chExt cx="0" cy="0"/>
+        </a:xfrm>
+      </p:grpSpPr>
+      <p:sp>
+        <p:nvSpPr>
+          <p:cNvPr id="4" name="직사각형 3">
+            <a:extLst>
+              <a:ext uri="{FF2B5EF4-FFF2-40B4-BE49-F238E27FC236}">
+                <a16:creationId xmlns:a16="http://schemas.microsoft.com/office/drawing/2014/main" id="{74BE4700-A4F9-1D77-3DF7-21D7DD269E9A}"/>
+              </a:ext>
+            </a:extLst>
+          </p:cNvPr>
+          <p:cNvSpPr/>
+          <p:nvPr/>
+        </p:nvSpPr>
+        <p:spPr>
+          <a:xfrm>
+            <a:off x="1981200" y="1133475"/>
+            <a:ext cx="2476500" cy="1333500"/>
+          </a:xfrm>
+          <a:prstGeom prst="rect">
+            <a:avLst/>
+          </a:prstGeom>
+          <a:noFill/>
+        </p:spPr>
+        <p:style>
+          <a:lnRef idx="2">
+            <a:schemeClr val="accent1">
+              <a:shade val="15000"/>
+            </a:schemeClr>
+          </a:lnRef>
+          <a:fillRef idx="1">
+            <a:schemeClr val="accent1"/>
+          </a:fillRef>
+          <a:effectRef idx="0">
+            <a:schemeClr val="accent1"/>
+          </a:effectRef>
+          <a:fontRef idx="minor">
+            <a:schemeClr val="lt1"/>
+          </a:fontRef>
+        </p:style>
+        <p:txBody>
+          <a:bodyPr rtlCol="0" anchor="ctr"/>
+          <a:lstStyle/>
+          <a:p>
+            <a:pPr algn="ctr"/>
+            <a:endParaRPr lang="ko-KR" altLang="en-US"/>
+          </a:p>
+        </p:txBody>
+      </p:sp>
+      <p:sp>
+        <p:nvSpPr>
+          <p:cNvPr id="5" name="순서도: 연결자 4">
+            <a:extLst>
+              <a:ext uri="{FF2B5EF4-FFF2-40B4-BE49-F238E27FC236}">
+                <a16:creationId xmlns:a16="http://schemas.microsoft.com/office/drawing/2014/main" id="{A2F6BA2A-8E4C-FE1E-A624-0D69A0B22F4C}"/>
+              </a:ext>
+            </a:extLst>
+          </p:cNvPr>
+          <p:cNvSpPr/>
+          <p:nvPr/>
+        </p:nvSpPr>
+        <p:spPr>
+          <a:xfrm>
+            <a:off x="6515100" y="2085975"/>
+            <a:ext cx="457200" cy="457200"/>
+          </a:xfrm>
+          <a:prstGeom prst="flowChartConnector">
+            <a:avLst/>
+          </a:prstGeom>
+          <a:noFill/>
+        </p:spPr>
+        <p:style>
+          <a:lnRef idx="2">
+            <a:schemeClr val="accent1">
+              <a:shade val="15000"/>
+            </a:schemeClr>
+          </a:lnRef>
+          <a:fillRef idx="1">
+            <a:schemeClr val="accent1"/>
+          </a:fillRef>
+          <a:effectRef idx="0">
+            <a:schemeClr val="accent1"/>
+          </a:effectRef>
+          <a:fontRef idx="minor">
+            <a:schemeClr val="lt1"/>
+          </a:fontRef>
+        </p:style>
+        <p:txBody>
+          <a:bodyPr rtlCol="0" anchor="ctr"/>
+          <a:lstStyle/>
+          <a:p>
+            <a:pPr algn="ctr"/>
+            <a:endParaRPr lang="ko-KR" altLang="en-US"/>
+          </a:p>
+        </p:txBody>
+      </p:sp>
+    </p:spTree>
+    <p:extLst>
+      <p:ext uri="{BB962C8B-B14F-4D97-AF65-F5344CB8AC3E}">
+        <p14:creationId xmlns:p14="http://schemas.microsoft.com/office/powerpoint/2010/main" val="3446981355"/>
+      </p:ext>
+    </p:extLst>
+  </p:cSld>
+  <p:clrMapOvr>
+    <a:masterClrMapping/>
+  </p:clrMapOvr>
+</p:sld>
+</file>
+
+<file path=ppt/slides/slide5.xml><?xml version="1.0" encoding="utf-8"?>
+<p:sld xmlns:a="http://schemas.openxmlformats.org/drawingml/2006/main" xmlns:r="http://schemas.openxmlformats.org/officeDocument/2006/relationships" xmlns:p="http://schemas.openxmlformats.org/presentationml/2006/main">
+  <p:cSld>
+    <p:spTree>
+      <p:nvGrpSpPr>
+        <p:cNvPr id="1" name=""/>
+        <p:cNvGrpSpPr/>
+        <p:nvPr/>
+      </p:nvGrpSpPr>
+      <p:grpSpPr>
+        <a:xfrm>
+          <a:off x="0" y="0"/>
+          <a:ext cx="0" cy="0"/>
+          <a:chOff x="0" y="0"/>
+          <a:chExt cx="0" cy="0"/>
+        </a:xfrm>
+      </p:grpSpPr>
+      <p:sp>
+        <p:nvSpPr>
+          <p:cNvPr id="5" name="TextBox 4">
+            <a:extLst>
+              <a:ext uri="{FF2B5EF4-FFF2-40B4-BE49-F238E27FC236}">
+                <a16:creationId xmlns:a16="http://schemas.microsoft.com/office/drawing/2014/main" id="{6C42B800-B229-067A-6658-F88FB3123BF7}"/>
+              </a:ext>
+            </a:extLst>
+          </p:cNvPr>
+          <p:cNvSpPr txBox="1"/>
+          <p:nvPr/>
+        </p:nvSpPr>
+        <p:spPr>
+          <a:xfrm>
+            <a:off x="3514725" y="1409700"/>
+            <a:ext cx="962025" cy="369332"/>
+          </a:xfrm>
+          <a:prstGeom prst="rect">
+            <a:avLst/>
+          </a:prstGeom>
+          <a:noFill/>
+        </p:spPr>
+        <p:txBody>
+          <a:bodyPr wrap="square" rtlCol="0">
+            <a:spAutoFit/>
+          </a:bodyPr>
+          <a:lstStyle/>
+          <a:p>
+            <a:r>
+              <a:rPr lang="ko-KR" altLang="en-US"/>
+              <a:t>양회장</a:t>
+            </a:r>
+            <a:endParaRPr lang="ko-KR" altLang="en-US" dirty="0"/>
+          </a:p>
+        </p:txBody>
+      </p:sp>
+      <p:pic>
+        <p:nvPicPr>
+          <p:cNvPr id="7" name="그래픽 6" descr="사과 윤곽선">
+            <a:extLst>
+              <a:ext uri="{FF2B5EF4-FFF2-40B4-BE49-F238E27FC236}">
+                <a16:creationId xmlns:a16="http://schemas.microsoft.com/office/drawing/2014/main" id="{0A076B48-AD52-9278-401C-A244E73E654F}"/>
+              </a:ext>
+            </a:extLst>
+          </p:cNvPr>
+          <p:cNvPicPr>
+            <a:picLocks noChangeAspect="1"/>
+          </p:cNvPicPr>
+          <p:nvPr/>
+        </p:nvPicPr>
+        <p:blipFill>
+          <a:blip>
+            <a:extLst>
+              <a:ext uri="{96DAC541-7B7A-43D3-8B79-37D633B846F1}">
+                <asvg:svgBlip xmlns:asvg="http://schemas.microsoft.com/office/drawing/2016/SVG/main" r:embed="rId2"/>
+              </a:ext>
+            </a:extLst>
+          </a:blip>
+          <a:stretch>
+            <a:fillRect/>
+          </a:stretch>
+        </p:blipFill>
+        <p:spPr>
+          <a:xfrm>
+            <a:off x="147638" y="889516"/>
+            <a:ext cx="3238500" cy="3238500"/>
+          </a:xfrm>
+          <a:prstGeom prst="rect">
+            <a:avLst/>
+          </a:prstGeom>
+        </p:spPr>
+      </p:pic>
+      <p:sp>
+        <p:nvSpPr>
+          <p:cNvPr id="9" name="설명선: 오른쪽 화살표 8">
+            <a:extLst>
+              <a:ext uri="{FF2B5EF4-FFF2-40B4-BE49-F238E27FC236}">
+                <a16:creationId xmlns:a16="http://schemas.microsoft.com/office/drawing/2014/main" id="{E35A5D6D-B1DE-FB5D-11E2-449BF66080B9}"/>
+              </a:ext>
+            </a:extLst>
+          </p:cNvPr>
+          <p:cNvSpPr/>
+          <p:nvPr/>
+        </p:nvSpPr>
+        <p:spPr>
+          <a:xfrm>
+            <a:off x="7972425" y="1594366"/>
+            <a:ext cx="914400" cy="914400"/>
+          </a:xfrm>
+          <a:prstGeom prst="rightArrowCallout">
+            <a:avLst/>
+          </a:prstGeom>
+          <a:noFill/>
+        </p:spPr>
+        <p:style>
+          <a:lnRef idx="2">
+            <a:schemeClr val="accent1">
+              <a:shade val="15000"/>
+            </a:schemeClr>
+          </a:lnRef>
+          <a:fillRef idx="1">
+            <a:schemeClr val="accent1"/>
+          </a:fillRef>
+          <a:effectRef idx="0">
+            <a:schemeClr val="accent1"/>
+          </a:effectRef>
+          <a:fontRef idx="minor">
+            <a:schemeClr val="lt1"/>
+          </a:fontRef>
+        </p:style>
+        <p:txBody>
+          <a:bodyPr rtlCol="0" anchor="ctr"/>
+          <a:lstStyle/>
+          <a:p>
+            <a:pPr algn="ctr"/>
+            <a:endParaRPr lang="ko-KR" altLang="en-US"/>
+          </a:p>
+        </p:txBody>
+      </p:sp>
+      <p:sp>
+        <p:nvSpPr>
+          <p:cNvPr id="11" name="TextBox 10">
+            <a:extLst>
+              <a:ext uri="{FF2B5EF4-FFF2-40B4-BE49-F238E27FC236}">
+                <a16:creationId xmlns:a16="http://schemas.microsoft.com/office/drawing/2014/main" id="{AAC86F83-AE78-38A4-525E-81269764F847}"/>
+              </a:ext>
+            </a:extLst>
+          </p:cNvPr>
+          <p:cNvSpPr txBox="1"/>
+          <p:nvPr/>
+        </p:nvSpPr>
+        <p:spPr>
+          <a:xfrm>
+            <a:off x="4476750" y="3048000"/>
+            <a:ext cx="2914650" cy="830997"/>
+          </a:xfrm>
+          <a:prstGeom prst="rect">
+            <a:avLst/>
+          </a:prstGeom>
+          <a:solidFill>
+            <a:schemeClr val="bg1"/>
+          </a:solidFill>
+          <a:ln>
+            <a:noFill/>
+          </a:ln>
+        </p:spPr>
+        <p:txBody>
+          <a:bodyPr wrap="square" rtlCol="0">
+            <a:spAutoFit/>
+          </a:bodyPr>
+          <a:lstStyle/>
+          <a:p>
+            <a:r>
+              <a:rPr lang="ko-KR" altLang="en-US" sz="4800" dirty="0"/>
+              <a:t>가나다</a:t>
+            </a:r>
+          </a:p>
+        </p:txBody>
+      </p:sp>
+      <p:sp>
+        <p:nvSpPr>
+          <p:cNvPr id="13" name="직사각형 12">
+            <a:extLst>
+              <a:ext uri="{FF2B5EF4-FFF2-40B4-BE49-F238E27FC236}">
+                <a16:creationId xmlns:a16="http://schemas.microsoft.com/office/drawing/2014/main" id="{B2FF0C22-6EC2-D2CD-F3BC-EA7437857623}"/>
+              </a:ext>
+            </a:extLst>
+          </p:cNvPr>
+          <p:cNvSpPr/>
+          <p:nvPr/>
+        </p:nvSpPr>
+        <p:spPr>
+          <a:xfrm>
+            <a:off x="4389745" y="4473654"/>
+            <a:ext cx="3679213" cy="923330"/>
+          </a:xfrm>
+          <a:prstGeom prst="rect">
+            <a:avLst/>
+          </a:prstGeom>
+          <a:noFill/>
+        </p:spPr>
+        <p:txBody>
+          <a:bodyPr wrap="none" lIns="91440" tIns="45720" rIns="91440" bIns="45720">
+            <a:spAutoFit/>
+          </a:bodyPr>
+          <a:lstStyle/>
+          <a:p>
+            <a:pPr algn="ctr"/>
+            <a:r>
+              <a:rPr lang="ko-KR" altLang="en-US" sz="5400" b="1" cap="none" spc="50" dirty="0" err="1">
+                <a:ln w="9525" cmpd="sng">
+                  <a:solidFill>
+                    <a:schemeClr val="accent1"/>
+                  </a:solidFill>
+                  <a:prstDash val="solid"/>
+                </a:ln>
+                <a:solidFill>
+                  <a:srgbClr val="70AD47">
+                    <a:tint val="1000"/>
+                  </a:srgbClr>
+                </a:solidFill>
+                <a:effectLst>
+                  <a:glow rad="38100">
+                    <a:schemeClr val="accent1">
+                      <a:alpha val="40000"/>
+                    </a:schemeClr>
+                  </a:glow>
+                </a:effectLst>
+              </a:rPr>
+              <a:t>양영권회장</a:t>
+            </a:r>
+            <a:endParaRPr lang="en-US" altLang="ko-KR" sz="5400" b="1" cap="none" spc="50" dirty="0">
+              <a:ln w="9525" cmpd="sng">
+                <a:solidFill>
+                  <a:schemeClr val="accent1"/>
+                </a:solidFill>
+                <a:prstDash val="solid"/>
+              </a:ln>
+              <a:solidFill>
+                <a:srgbClr val="70AD47">
+                  <a:tint val="1000"/>
+                </a:srgbClr>
+              </a:solidFill>
+              <a:effectLst>
+                <a:glow rad="38100">
+                  <a:schemeClr val="accent1">
+                    <a:alpha val="40000"/>
+                  </a:schemeClr>
+                </a:glow>
+              </a:effectLst>
+            </a:endParaRPr>
+          </a:p>
+        </p:txBody>
+      </p:sp>
+      <p:sp>
+        <p:nvSpPr>
+          <p:cNvPr id="15" name="직사각형 14">
+            <a:extLst>
+              <a:ext uri="{FF2B5EF4-FFF2-40B4-BE49-F238E27FC236}">
+                <a16:creationId xmlns:a16="http://schemas.microsoft.com/office/drawing/2014/main" id="{6D6CC8A8-850F-8149-E8F6-94EA669F2EBC}"/>
+              </a:ext>
+            </a:extLst>
+          </p:cNvPr>
+          <p:cNvSpPr/>
+          <p:nvPr/>
+        </p:nvSpPr>
+        <p:spPr>
+          <a:xfrm>
+            <a:off x="4421805" y="5396984"/>
+            <a:ext cx="3647153" cy="923330"/>
+          </a:xfrm>
+          <a:prstGeom prst="rect">
+            <a:avLst/>
+          </a:prstGeom>
+          <a:noFill/>
+        </p:spPr>
+        <p:txBody>
+          <a:bodyPr wrap="none" lIns="91440" tIns="45720" rIns="91440" bIns="45720">
+            <a:spAutoFit/>
+          </a:bodyPr>
+          <a:lstStyle/>
+          <a:p>
+            <a:pPr algn="ctr"/>
+            <a:r>
+              <a:rPr lang="ko-KR" altLang="en-US" sz="5400" b="1" cap="none" spc="0" dirty="0" err="1">
+                <a:ln w="10160">
+                  <a:solidFill>
+                    <a:schemeClr val="accent5"/>
+                  </a:solidFill>
+                  <a:prstDash val="solid"/>
+                </a:ln>
+                <a:solidFill>
+                  <a:srgbClr val="FFFFFF"/>
+                </a:solidFill>
+              </a:rPr>
+              <a:t>양영권회장</a:t>
+            </a:r>
+            <a:endParaRPr lang="en-US" altLang="ko-KR" sz="5400" b="1" cap="none" spc="0" dirty="0">
+              <a:ln w="10160">
+                <a:solidFill>
+                  <a:schemeClr val="accent5"/>
+                </a:solidFill>
+                <a:prstDash val="solid"/>
+              </a:ln>
+              <a:solidFill>
+                <a:srgbClr val="FFFFFF"/>
+              </a:solidFill>
+            </a:endParaRPr>
+          </a:p>
+        </p:txBody>
+      </p:sp>
+    </p:spTree>
+    <p:extLst>
+      <p:ext uri="{BB962C8B-B14F-4D97-AF65-F5344CB8AC3E}">
+        <p14:creationId xmlns:p14="http://schemas.microsoft.com/office/powerpoint/2010/main" val="1402187863"/>
+      </p:ext>
+    </p:extLst>
+  </p:cSld>
+  <p:clrMapOvr>
+    <a:masterClrMapping/>
+  </p:clrMapOvr>
+</p:sld>
+</file>
+
 <file path=ppt/theme/theme1.xml><?xml version="1.0" encoding="utf-8"?>
 <a:theme xmlns:a="http://schemas.openxmlformats.org/drawingml/2006/main" name="Office 테마">
   <a:themeElements>

</xml_diff>